<commit_message>
isa444 fall2025 class01 v1.1
</commit_message>
<xml_diff>
--- a/ppts/01_intro.pptx
+++ b/ppts/01_intro.pptx
@@ -2221,7 +2221,7 @@
             </a:pPr>
             <a:fld id="{81D60167-4931-47E6-BA6A-407CBD079E47}" type="slidenum">
               <a:rPr dirty="0"/>
-              <a:t>10</a:t>
+              <a:t>11</a:t>
             </a:fld>
             <a:r>
               <a:rPr dirty="0"/>
@@ -3580,7 +3580,7 @@
         <p:spPr>
           <a:xfrm>
             <a:off x="1130300" y="1673225"/>
-            <a:ext cx="9462770" cy="4004945"/>
+            <a:ext cx="9462770" cy="4643120"/>
           </a:xfrm>
           <a:prstGeom prst="rect">
             <a:avLst/>
@@ -3614,9 +3614,18 @@
                 </a:solidFill>
                 <a:latin typeface="Roboto"/>
                 <a:cs typeface="Roboto"/>
-                <a:hlinkClick r:id="rId2"/>
-              </a:rPr>
-              <a:t>Description</a:t>
+              </a:rPr>
+              <a:t>Description	</a:t>
+            </a:r>
+            <a:r>
+              <a:rPr dirty="0" sz="1800" spc="-15">
+                <a:solidFill>
+                  <a:srgbClr val="585D60"/>
+                </a:solidFill>
+                <a:latin typeface="Roboto"/>
+                <a:cs typeface="Roboto"/>
+              </a:rPr>
+              <a:t>Your</a:t>
             </a:r>
             <a:r>
               <a:rPr dirty="0" sz="1800">
@@ -3626,7 +3635,7 @@
                 <a:latin typeface="Roboto"/>
                 <a:cs typeface="Roboto"/>
               </a:rPr>
-              <a:t>	</a:t>
+              <a:t> Logic	</a:t>
             </a:r>
             <a:r>
               <a:rPr dirty="0" sz="1800" spc="-15">
@@ -3635,7 +3644,6 @@
                 </a:solidFill>
                 <a:latin typeface="Roboto"/>
                 <a:cs typeface="Roboto"/>
-                <a:hlinkClick r:id="rId3"/>
               </a:rPr>
               <a:t>Your</a:t>
             </a:r>
@@ -3646,72 +3654,8 @@
                 </a:solidFill>
                 <a:latin typeface="Roboto"/>
                 <a:cs typeface="Roboto"/>
-                <a:hlinkClick r:id="rId3"/>
-              </a:rPr>
-              <a:t> Logic</a:t>
-            </a:r>
-            <a:r>
-              <a:rPr dirty="0" sz="1800">
-                <a:solidFill>
-                  <a:srgbClr val="585D60"/>
-                </a:solidFill>
-                <a:latin typeface="Roboto"/>
-                <a:cs typeface="Roboto"/>
-              </a:rPr>
-              <a:t>	</a:t>
-            </a:r>
-            <a:r>
-              <a:rPr dirty="0" sz="1800" spc="-15">
-                <a:solidFill>
-                  <a:srgbClr val="585D60"/>
-                </a:solidFill>
-                <a:latin typeface="Roboto"/>
-                <a:cs typeface="Roboto"/>
-                <a:hlinkClick r:id="rId4"/>
-              </a:rPr>
-              <a:t>Your</a:t>
-            </a:r>
-            <a:r>
-              <a:rPr dirty="0" sz="1800">
-                <a:solidFill>
-                  <a:srgbClr val="585D60"/>
-                </a:solidFill>
-                <a:latin typeface="Roboto"/>
-                <a:cs typeface="Roboto"/>
-                <a:hlinkClick r:id="rId4"/>
-              </a:rPr>
-              <a:t> Sol</a:t>
-            </a:r>
-            <a:r>
-              <a:rPr dirty="0" sz="1800">
-                <a:solidFill>
-                  <a:srgbClr val="585D60"/>
-                </a:solidFill>
-                <a:latin typeface="Roboto"/>
-                <a:cs typeface="Roboto"/>
-              </a:rPr>
-              <a:t>	</a:t>
-            </a:r>
-            <a:r>
-              <a:rPr dirty="0" sz="1800">
-                <a:solidFill>
-                  <a:srgbClr val="585D60"/>
-                </a:solidFill>
-                <a:latin typeface="Roboto"/>
-                <a:cs typeface="Roboto"/>
-                <a:hlinkClick r:id="rId5"/>
-              </a:rPr>
-              <a:t>Class Results</a:t>
-            </a:r>
-            <a:r>
-              <a:rPr dirty="0" sz="1800">
-                <a:solidFill>
-                  <a:srgbClr val="585D60"/>
-                </a:solidFill>
-                <a:latin typeface="Roboto"/>
-                <a:cs typeface="Roboto"/>
-              </a:rPr>
-              <a:t>	</a:t>
+              </a:rPr>
+              <a:t> Sol	Class Results	</a:t>
             </a:r>
             <a:r>
               <a:rPr dirty="0" sz="1800" spc="-15">
@@ -3783,7 +3727,7 @@
             </a:endParaRPr>
           </a:p>
           <a:p>
-            <a:pPr algn="just" marL="165100" indent="-133985">
+            <a:pPr marL="165100" indent="-133985">
               <a:lnSpc>
                 <a:spcPct val="100000"/>
               </a:lnSpc>
@@ -3872,7 +3816,7 @@
             </a:endParaRPr>
           </a:p>
           <a:p>
-            <a:pPr algn="just" marL="165100" indent="-133985">
+            <a:pPr marL="165100" indent="-133985">
               <a:lnSpc>
                 <a:spcPct val="100000"/>
               </a:lnSpc>
@@ -3991,12 +3935,12 @@
             </a:endParaRPr>
           </a:p>
           <a:p>
-            <a:pPr algn="just" marL="164465" marR="5080" indent="-133985">
+            <a:pPr marL="164465" marR="5080" indent="-133985">
               <a:lnSpc>
-                <a:spcPct val="118100"/>
+                <a:spcPct val="116900"/>
               </a:lnSpc>
               <a:spcBef>
-                <a:spcPts val="819"/>
+                <a:spcPts val="850"/>
               </a:spcBef>
               <a:buFont typeface="Roboto"/>
               <a:buChar char="•"/>
@@ -4162,7 +4106,7 @@
                 <a:latin typeface="Roboto"/>
                 <a:cs typeface="Roboto"/>
               </a:rPr>
-              <a:t>file</a:t>
+              <a:t>file  </a:t>
             </a:r>
             <a:r>
               <a:rPr dirty="0" sz="1800" spc="-5">
@@ -4172,28 +4116,50 @@
                 <a:latin typeface="Roboto"/>
                 <a:cs typeface="Roboto"/>
               </a:rPr>
+              <a:t>[here]</a:t>
+            </a:r>
+            <a:r>
+              <a:rPr dirty="0" sz="1800" spc="-5">
+                <a:solidFill>
+                  <a:srgbClr val="83D5D3"/>
+                </a:solidFill>
+                <a:latin typeface="Roboto"/>
+                <a:cs typeface="Roboto"/>
+                <a:hlinkClick r:id="rId2"/>
+              </a:rPr>
+              <a:t>https://miamioh.instructure.com/courses/240425/files/36340085? </a:t>
+            </a:r>
+            <a:r>
+              <a:rPr dirty="0" sz="1800" spc="-5">
+                <a:solidFill>
+                  <a:srgbClr val="83D5D3"/>
+                </a:solidFill>
+                <a:latin typeface="Roboto"/>
+                <a:cs typeface="Roboto"/>
+                <a:hlinkClick r:id="rId2"/>
+              </a:rPr>
               <a:t> </a:t>
             </a:r>
             <a:r>
-              <a:rPr dirty="0" sz="1800" spc="-5">
+              <a:rPr dirty="0" sz="1800">
                 <a:solidFill>
                   <a:srgbClr val="83D5D3"/>
                 </a:solidFill>
                 <a:latin typeface="Roboto"/>
                 <a:cs typeface="Roboto"/>
-                <a:hlinkClick r:id="rId6"/>
-              </a:rPr>
-              <a:t>here</a:t>
-            </a:r>
-            <a:r>
-              <a:rPr dirty="0" sz="1800" spc="-5">
-                <a:solidFill>
-                  <a:srgbClr val="585D60"/>
-                </a:solidFill>
-                <a:latin typeface="Roboto"/>
-                <a:cs typeface="Roboto"/>
-              </a:rPr>
-              <a:t>.</a:t>
+                <a:hlinkClick r:id="rId2"/>
+              </a:rPr>
+              <a:t>module_item_id=6161473</a:t>
+            </a:r>
+            <a:r>
+              <a:rPr dirty="0" sz="1800">
+                <a:solidFill>
+                  <a:srgbClr val="585D60"/>
+                </a:solidFill>
+                <a:latin typeface="Roboto"/>
+                <a:cs typeface="Roboto"/>
+              </a:rPr>
+              <a:t>).</a:t>
             </a:r>
             <a:endParaRPr sz="1800">
               <a:latin typeface="Roboto"/>
@@ -4203,10 +4169,10 @@
           <a:p>
             <a:pPr algn="just" marL="164465" marR="367030" indent="-133985">
               <a:lnSpc>
-                <a:spcPct val="118100"/>
+                <a:spcPct val="116300"/>
               </a:lnSpc>
               <a:spcBef>
-                <a:spcPts val="825"/>
+                <a:spcPts val="935"/>
               </a:spcBef>
               <a:buFont typeface="Roboto"/>
               <a:buChar char="•"/>
@@ -5122,7 +5088,7 @@
             </a:pPr>
             <a:fld id="{81D60167-4931-47E6-BA6A-407CBD079E47}" type="slidenum">
               <a:rPr dirty="0"/>
-              <a:t>10</a:t>
+              <a:t>11</a:t>
             </a:fld>
             <a:r>
               <a:rPr dirty="0"/>
@@ -25007,9 +24973,18 @@
                 </a:solidFill>
                 <a:latin typeface="Roboto"/>
                 <a:cs typeface="Roboto"/>
-                <a:hlinkClick r:id="rId2"/>
-              </a:rPr>
-              <a:t>Description</a:t>
+              </a:rPr>
+              <a:t>Description	Scenarios	Class</a:t>
+            </a:r>
+            <a:r>
+              <a:rPr dirty="0" sz="1800" spc="-5">
+                <a:solidFill>
+                  <a:srgbClr val="585D60"/>
+                </a:solidFill>
+                <a:latin typeface="Roboto"/>
+                <a:cs typeface="Roboto"/>
+              </a:rPr>
+              <a:t> </a:t>
             </a:r>
             <a:r>
               <a:rPr dirty="0" sz="1800">
@@ -25018,60 +24993,6 @@
                 </a:solidFill>
                 <a:latin typeface="Roboto"/>
                 <a:cs typeface="Roboto"/>
-              </a:rPr>
-              <a:t>	</a:t>
-            </a:r>
-            <a:r>
-              <a:rPr dirty="0" sz="1800">
-                <a:solidFill>
-                  <a:srgbClr val="585D60"/>
-                </a:solidFill>
-                <a:latin typeface="Roboto"/>
-                <a:cs typeface="Roboto"/>
-                <a:hlinkClick r:id="rId3"/>
-              </a:rPr>
-              <a:t>Scenarios</a:t>
-            </a:r>
-            <a:r>
-              <a:rPr dirty="0" sz="1800">
-                <a:solidFill>
-                  <a:srgbClr val="585D60"/>
-                </a:solidFill>
-                <a:latin typeface="Roboto"/>
-                <a:cs typeface="Roboto"/>
-              </a:rPr>
-              <a:t>	</a:t>
-            </a:r>
-            <a:r>
-              <a:rPr dirty="0" sz="1800">
-                <a:solidFill>
-                  <a:srgbClr val="585D60"/>
-                </a:solidFill>
-                <a:latin typeface="Roboto"/>
-                <a:cs typeface="Roboto"/>
-                <a:hlinkClick r:id="rId4"/>
-              </a:rPr>
-              <a:t>Class</a:t>
-            </a:r>
-            <a:r>
-              <a:rPr dirty="0" sz="1800" spc="-5">
-                <a:solidFill>
-                  <a:srgbClr val="585D60"/>
-                </a:solidFill>
-                <a:latin typeface="Roboto"/>
-                <a:cs typeface="Roboto"/>
-                <a:hlinkClick r:id="rId4"/>
-              </a:rPr>
-              <a:t> </a:t>
-            </a:r>
-            <a:r>
-              <a:rPr dirty="0" sz="1800">
-                <a:solidFill>
-                  <a:srgbClr val="585D60"/>
-                </a:solidFill>
-                <a:latin typeface="Roboto"/>
-                <a:cs typeface="Roboto"/>
-                <a:hlinkClick r:id="rId4"/>
               </a:rPr>
               <a:t>Results</a:t>
             </a:r>
@@ -25304,7 +25225,7 @@
                 </a:solidFill>
                 <a:latin typeface="Roboto"/>
                 <a:cs typeface="Roboto"/>
-                <a:hlinkClick r:id="rId5"/>
+                <a:hlinkClick r:id="rId2"/>
               </a:rPr>
               <a:t>here</a:t>
             </a:r>
@@ -37559,7 +37480,7 @@
             </a:pPr>
             <a:fld id="{81D60167-4931-47E6-BA6A-407CBD079E47}" type="slidenum">
               <a:rPr dirty="0"/>
-              <a:t>10</a:t>
+              <a:t>11</a:t>
             </a:fld>
             <a:r>
               <a:rPr dirty="0"/>
@@ -40445,7 +40366,7 @@
             </a:pPr>
             <a:fld id="{81D60167-4931-47E6-BA6A-407CBD079E47}" type="slidenum">
               <a:rPr dirty="0"/>
-              <a:t>10</a:t>
+              <a:t>11</a:t>
             </a:fld>
             <a:r>
               <a:rPr dirty="0"/>
@@ -40730,7 +40651,7 @@
             </a:pPr>
             <a:fld id="{81D60167-4931-47E6-BA6A-407CBD079E47}" type="slidenum">
               <a:rPr dirty="0"/>
-              <a:t>10</a:t>
+              <a:t>11</a:t>
             </a:fld>
             <a:r>
               <a:rPr dirty="0"/>
@@ -42161,7 +42082,7 @@
             </a:pPr>
             <a:fld id="{81D60167-4931-47E6-BA6A-407CBD079E47}" type="slidenum">
               <a:rPr dirty="0"/>
-              <a:t>10</a:t>
+              <a:t>11</a:t>
             </a:fld>
             <a:r>
               <a:rPr dirty="0"/>
@@ -42426,7 +42347,7 @@
             </a:pPr>
             <a:fld id="{81D60167-4931-47E6-BA6A-407CBD079E47}" type="slidenum">
               <a:rPr dirty="0"/>
-              <a:t>10</a:t>
+              <a:t>11</a:t>
             </a:fld>
             <a:r>
               <a:rPr dirty="0"/>
@@ -42597,7 +42518,7 @@
             </a:pPr>
             <a:fld id="{81D60167-4931-47E6-BA6A-407CBD079E47}" type="slidenum">
               <a:rPr dirty="0"/>
-              <a:t>10</a:t>
+              <a:t>11</a:t>
             </a:fld>
             <a:r>
               <a:rPr dirty="0"/>

</xml_diff>